<commit_message>
Block unsupported HTTP claims in generated answers
</commit_message>
<xml_diff>
--- a/docs/FaultTrace_5_Minute_Presentation.pptx
+++ b/docs/FaultTrace_5_Minute_Presentation.pptx
@@ -2,18 +2,18 @@
 <file path=ppt/presentation.xml><?xml version="1.0" encoding="utf-8"?>
 <p:presentation xmlns:p="http://schemas.openxmlformats.org/presentationml/2006/main">
   <p:sldMasterIdLst>
-    <p:sldMasterId xmlns:r="http://schemas.openxmlformats.org/officeDocument/2006/relationships" id="2147483648" r:id="R23349ec81b454dfe"/>
+    <p:sldMasterId xmlns:r="http://schemas.openxmlformats.org/officeDocument/2006/relationships" id="2147483648" r:id="R60907a2ecdfc4d68"/>
   </p:sldMasterIdLst>
   <p:notesMasterIdLst>
-    <p:notesMasterId xmlns:r="http://schemas.openxmlformats.org/officeDocument/2006/relationships" r:id="Ra543c30dc31b4567"/>
+    <p:notesMasterId xmlns:r="http://schemas.openxmlformats.org/officeDocument/2006/relationships" r:id="R12980f1cc19841d9"/>
   </p:notesMasterIdLst>
   <p:sldIdLst>
-    <p:sldId xmlns:r="http://schemas.openxmlformats.org/officeDocument/2006/relationships" id="256" r:id="R49fb08a47ad84ebd"/>
-    <p:sldId xmlns:r="http://schemas.openxmlformats.org/officeDocument/2006/relationships" id="257" r:id="R45a6ea1e75764986"/>
-    <p:sldId xmlns:r="http://schemas.openxmlformats.org/officeDocument/2006/relationships" id="258" r:id="R69cd9c1e27424ce5"/>
-    <p:sldId xmlns:r="http://schemas.openxmlformats.org/officeDocument/2006/relationships" id="259" r:id="Rea7f5ad484744158"/>
-    <p:sldId xmlns:r="http://schemas.openxmlformats.org/officeDocument/2006/relationships" id="260" r:id="R9d0dfa081bb34f83"/>
-    <p:sldId xmlns:r="http://schemas.openxmlformats.org/officeDocument/2006/relationships" id="261" r:id="Re346024da3184c15"/>
+    <p:sldId xmlns:r="http://schemas.openxmlformats.org/officeDocument/2006/relationships" id="256" r:id="Rf79ae55c2fe745cf"/>
+    <p:sldId xmlns:r="http://schemas.openxmlformats.org/officeDocument/2006/relationships" id="257" r:id="R43bedd9ba29e4288"/>
+    <p:sldId xmlns:r="http://schemas.openxmlformats.org/officeDocument/2006/relationships" id="258" r:id="R300981bfbf334ba9"/>
+    <p:sldId xmlns:r="http://schemas.openxmlformats.org/officeDocument/2006/relationships" id="259" r:id="R286e4e244fae407a"/>
+    <p:sldId xmlns:r="http://schemas.openxmlformats.org/officeDocument/2006/relationships" id="260" r:id="R832ded7f4f034b8c"/>
+    <p:sldId xmlns:r="http://schemas.openxmlformats.org/officeDocument/2006/relationships" id="261" r:id="R0d205b47a8304fa9"/>
   </p:sldIdLst>
   <p:sldSz cx="12192000" cy="6858000"/>
   <p:notesSz cx="6858000" cy="9144000"/>
@@ -1040,7 +1040,7 @@
   </p:cSld>
   <p:clrMap bg1="lt1" tx1="dk1" bg2="lt2" tx2="dk2" accent1="accent1" accent2="accent2" accent3="accent3" accent4="accent4" accent5="accent5" accent6="accent6" hlink="hlink" folHlink="folHlink"/>
   <p:sldLayoutIdLst>
-    <p:sldLayoutId xmlns:r="http://schemas.openxmlformats.org/officeDocument/2006/relationships" id="2147483649" r:id="R95bcfb1ceb3d41a1"/>
+    <p:sldLayoutId xmlns:r="http://schemas.openxmlformats.org/officeDocument/2006/relationships" id="2147483649" r:id="R45b52882400c487c"/>
   </p:sldLayoutIdLst>
   <p:txStyles>
     <p:titleStyle>
@@ -1591,7 +1591,7 @@
           <p:cNvPr id="5" name="Title-3-1">
             <a:extLst xmlns:a="http://schemas.openxmlformats.org/drawingml/2006/main">
               <a:ext uri="{FF2B5EF4-FFF2-40B4-BE49-F238E27FC236}">
-                <a16:creationId xmlns:a16="http://schemas.microsoft.com/office/drawing/2014/main" id="{9DA21DCC-68D5-4A16-A6EE-195470D96C39}"/>
+                <a16:creationId xmlns:a16="http://schemas.microsoft.com/office/drawing/2014/main" id="{DEB44865-5B40-4A66-8BA3-1DA3F4582A43}"/>
               </a:ext>
             </a:extLst>
           </p:cNvPr>
@@ -1648,7 +1648,7 @@
           <p:cNvPr id="2" name="Subtitle-4-2">
             <a:extLst xmlns:a="http://schemas.openxmlformats.org/drawingml/2006/main">
               <a:ext uri="{FF2B5EF4-FFF2-40B4-BE49-F238E27FC236}">
-                <a16:creationId xmlns:a16="http://schemas.microsoft.com/office/drawing/2014/main" id="{CB2D8379-6FBB-49DB-B6BF-D6E1E697CF4A}"/>
+                <a16:creationId xmlns:a16="http://schemas.microsoft.com/office/drawing/2014/main" id="{12AD8436-767F-4879-A8B9-FA7899883E27}"/>
               </a:ext>
             </a:extLst>
           </p:cNvPr>
@@ -1705,7 +1705,7 @@
           <p:cNvPr id="3" name="Subtitle-4-3">
             <a:extLst xmlns:a="http://schemas.openxmlformats.org/drawingml/2006/main">
               <a:ext uri="{FF2B5EF4-FFF2-40B4-BE49-F238E27FC236}">
-                <a16:creationId xmlns:a16="http://schemas.microsoft.com/office/drawing/2014/main" id="{7D864348-0155-4C23-ADE1-6D3646044336}"/>
+                <a16:creationId xmlns:a16="http://schemas.microsoft.com/office/drawing/2014/main" id="{BBB58DDF-A5DA-4937-8AAD-3DA4565A4CE1}"/>
               </a:ext>
             </a:extLst>
           </p:cNvPr>
@@ -1762,7 +1762,7 @@
           <p:cNvPr id="4" name="accent-1">
             <a:extLst xmlns:a="http://schemas.openxmlformats.org/drawingml/2006/main">
               <a:ext uri="{FF2B5EF4-FFF2-40B4-BE49-F238E27FC236}">
-                <a16:creationId xmlns:a16="http://schemas.microsoft.com/office/drawing/2014/main" id="{4348478F-3D93-4AD3-BC2D-0B0EE78F20F6}"/>
+                <a16:creationId xmlns:a16="http://schemas.microsoft.com/office/drawing/2014/main" id="{A9D6C8B6-82E8-4744-8FF7-26E4428252C4}"/>
               </a:ext>
             </a:extLst>
           </p:cNvPr>
@@ -1793,7 +1793,7 @@
     </p:spTree>
     <p:extLst>
       <p:ext uri="{BB962C8B-B14F-4D97-AF65-F5344CB8AC3E}">
-        <p14:creationId xmlns:p14="http://schemas.microsoft.com/office/powerpoint/2010/main" val="371971364"/>
+        <p14:creationId xmlns:p14="http://schemas.microsoft.com/office/powerpoint/2010/main" val="251773179"/>
       </p:ext>
     </p:extLst>
   </p:cSld>
@@ -1824,7 +1824,7 @@
           <p:cNvPr id="14" name="Google-Shape-532-p58-2">
             <a:extLst xmlns:a="http://schemas.openxmlformats.org/drawingml/2006/main">
               <a:ext uri="{FF2B5EF4-FFF2-40B4-BE49-F238E27FC236}">
-                <a16:creationId xmlns:a16="http://schemas.microsoft.com/office/drawing/2014/main" id="{8B6E4428-D8C0-44C9-9BD3-EB17A1451EB2}"/>
+                <a16:creationId xmlns:a16="http://schemas.microsoft.com/office/drawing/2014/main" id="{E1E823D0-18EB-47D0-B5B0-AEF2A4D6CF84}"/>
               </a:ext>
             </a:extLst>
           </p:cNvPr>
@@ -1869,7 +1869,7 @@
           <p:cNvPr id="2" name="Google-Shape-533-p58-3">
             <a:extLst xmlns:a="http://schemas.openxmlformats.org/drawingml/2006/main">
               <a:ext uri="{FF2B5EF4-FFF2-40B4-BE49-F238E27FC236}">
-                <a16:creationId xmlns:a16="http://schemas.microsoft.com/office/drawing/2014/main" id="{8EC88BFD-95EB-4843-ACDC-C51CE56266E1}"/>
+                <a16:creationId xmlns:a16="http://schemas.microsoft.com/office/drawing/2014/main" id="{8B376E27-ED3A-4E43-93B3-DEC426B40C8A}"/>
               </a:ext>
             </a:extLst>
           </p:cNvPr>
@@ -1926,7 +1926,7 @@
           <p:cNvPr id="3" name="Rounded-Rectangle-9-4">
             <a:extLst xmlns:a="http://schemas.openxmlformats.org/drawingml/2006/main">
               <a:ext uri="{FF2B5EF4-FFF2-40B4-BE49-F238E27FC236}">
-                <a16:creationId xmlns:a16="http://schemas.microsoft.com/office/drawing/2014/main" id="{541098AC-2B15-464E-93CE-37E78D028911}"/>
+                <a16:creationId xmlns:a16="http://schemas.microsoft.com/office/drawing/2014/main" id="{6BC1FC63-5861-4625-AB54-3A03E458813B}"/>
               </a:ext>
             </a:extLst>
           </p:cNvPr>
@@ -1955,7 +1955,7 @@
           <p:cNvPr id="4" name="Rounded-Rectangle-10-5">
             <a:extLst xmlns:a="http://schemas.openxmlformats.org/drawingml/2006/main">
               <a:ext uri="{FF2B5EF4-FFF2-40B4-BE49-F238E27FC236}">
-                <a16:creationId xmlns:a16="http://schemas.microsoft.com/office/drawing/2014/main" id="{8FE33835-8317-49D5-AEDF-DDA6F4D8B6D1}"/>
+                <a16:creationId xmlns:a16="http://schemas.microsoft.com/office/drawing/2014/main" id="{400D25B8-C725-45BE-880D-4702BE7E042D}"/>
               </a:ext>
             </a:extLst>
           </p:cNvPr>
@@ -1984,7 +1984,7 @@
           <p:cNvPr id="5" name="Content-Placeholder-9-6">
             <a:extLst xmlns:a="http://schemas.openxmlformats.org/drawingml/2006/main">
               <a:ext uri="{FF2B5EF4-FFF2-40B4-BE49-F238E27FC236}">
-                <a16:creationId xmlns:a16="http://schemas.microsoft.com/office/drawing/2014/main" id="{17547ADB-E5E6-4F7E-B323-BBC6F84E5AAE}"/>
+                <a16:creationId xmlns:a16="http://schemas.microsoft.com/office/drawing/2014/main" id="{352F32A0-75B8-4A0F-83DA-3D8BB7C610C3}"/>
               </a:ext>
             </a:extLst>
           </p:cNvPr>
@@ -2068,7 +2068,7 @@
           <p:cNvPr id="6" name="Content-Placeholder-10-7">
             <a:extLst xmlns:a="http://schemas.openxmlformats.org/drawingml/2006/main">
               <a:ext uri="{FF2B5EF4-FFF2-40B4-BE49-F238E27FC236}">
-                <a16:creationId xmlns:a16="http://schemas.microsoft.com/office/drawing/2014/main" id="{2FD96572-DF9A-4BD5-A1A4-43506548809F}"/>
+                <a16:creationId xmlns:a16="http://schemas.microsoft.com/office/drawing/2014/main" id="{8D730748-3773-45CF-8BDB-66F3DC0A63DD}"/>
               </a:ext>
             </a:extLst>
           </p:cNvPr>
@@ -2152,7 +2152,7 @@
           <p:cNvPr id="7" name="Google-Shape-340-p61-8">
             <a:extLst xmlns:a="http://schemas.openxmlformats.org/drawingml/2006/main">
               <a:ext uri="{FF2B5EF4-FFF2-40B4-BE49-F238E27FC236}">
-                <a16:creationId xmlns:a16="http://schemas.microsoft.com/office/drawing/2014/main" id="{385F07D1-A207-4151-B086-773953E2075D}"/>
+                <a16:creationId xmlns:a16="http://schemas.microsoft.com/office/drawing/2014/main" id="{8CC64178-4B7B-4BBC-8AA3-DBDF523C0BEF}"/>
               </a:ext>
             </a:extLst>
           </p:cNvPr>
@@ -2276,7 +2276,7 @@
           <p:cNvPr id="8" name="Google-Shape-340-p61-9">
             <a:extLst xmlns:a="http://schemas.openxmlformats.org/drawingml/2006/main">
               <a:ext uri="{FF2B5EF4-FFF2-40B4-BE49-F238E27FC236}">
-                <a16:creationId xmlns:a16="http://schemas.microsoft.com/office/drawing/2014/main" id="{379ED31D-3520-4EAA-B2C6-A89E7A9F87D7}"/>
+                <a16:creationId xmlns:a16="http://schemas.microsoft.com/office/drawing/2014/main" id="{17430167-6567-4676-ACCF-4BF2DD4FA3C8}"/>
               </a:ext>
             </a:extLst>
           </p:cNvPr>
@@ -2400,7 +2400,7 @@
           <p:cNvPr id="9" name="Rounded-Rectangle-5-10">
             <a:extLst xmlns:a="http://schemas.openxmlformats.org/drawingml/2006/main">
               <a:ext uri="{FF2B5EF4-FFF2-40B4-BE49-F238E27FC236}">
-                <a16:creationId xmlns:a16="http://schemas.microsoft.com/office/drawing/2014/main" id="{BF5D55B0-535D-45F9-8705-A04F8F43F01E}"/>
+                <a16:creationId xmlns:a16="http://schemas.microsoft.com/office/drawing/2014/main" id="{B1FFE009-6898-43DF-9C06-CFAF9CD344A8}"/>
               </a:ext>
             </a:extLst>
           </p:cNvPr>
@@ -2429,7 +2429,7 @@
           <p:cNvPr id="10" name="Content-Placeholder-9-11">
             <a:extLst xmlns:a="http://schemas.openxmlformats.org/drawingml/2006/main">
               <a:ext uri="{FF2B5EF4-FFF2-40B4-BE49-F238E27FC236}">
-                <a16:creationId xmlns:a16="http://schemas.microsoft.com/office/drawing/2014/main" id="{A66FFC85-7233-41F5-A8A9-641681ABCD3B}"/>
+                <a16:creationId xmlns:a16="http://schemas.microsoft.com/office/drawing/2014/main" id="{A8BA744C-A4CE-43AC-AB45-EC1CDDF2986C}"/>
               </a:ext>
             </a:extLst>
           </p:cNvPr>
@@ -2513,7 +2513,7 @@
           <p:cNvPr id="11" name="Google-Shape-340-p61-12">
             <a:extLst xmlns:a="http://schemas.openxmlformats.org/drawingml/2006/main">
               <a:ext uri="{FF2B5EF4-FFF2-40B4-BE49-F238E27FC236}">
-                <a16:creationId xmlns:a16="http://schemas.microsoft.com/office/drawing/2014/main" id="{55CB1C06-06F8-4E10-93A1-3A2BA81E3AFC}"/>
+                <a16:creationId xmlns:a16="http://schemas.microsoft.com/office/drawing/2014/main" id="{807687B0-FFCE-42D7-B90B-FF48B3F07063}"/>
               </a:ext>
             </a:extLst>
           </p:cNvPr>
@@ -2637,7 +2637,7 @@
           <p:cNvPr id="12" name="Content-Placeholder-15-13">
             <a:extLst xmlns:a="http://schemas.openxmlformats.org/drawingml/2006/main">
               <a:ext uri="{FF2B5EF4-FFF2-40B4-BE49-F238E27FC236}">
-                <a16:creationId xmlns:a16="http://schemas.microsoft.com/office/drawing/2014/main" id="{A9087AD6-B0E6-4E04-B812-783117D62AA1}"/>
+                <a16:creationId xmlns:a16="http://schemas.microsoft.com/office/drawing/2014/main" id="{ECD6D0E1-D964-4065-A795-AA5FA7B93AEA}"/>
               </a:ext>
             </a:extLst>
           </p:cNvPr>
@@ -2748,7 +2748,7 @@
           <p:cNvPr id="13" name="accent-2">
             <a:extLst xmlns:a="http://schemas.openxmlformats.org/drawingml/2006/main">
               <a:ext uri="{FF2B5EF4-FFF2-40B4-BE49-F238E27FC236}">
-                <a16:creationId xmlns:a16="http://schemas.microsoft.com/office/drawing/2014/main" id="{11A11A6E-28D6-44CE-8C6A-481A5815D811}"/>
+                <a16:creationId xmlns:a16="http://schemas.microsoft.com/office/drawing/2014/main" id="{74333901-449F-49A4-9D8B-2222C3171028}"/>
               </a:ext>
             </a:extLst>
           </p:cNvPr>
@@ -2779,7 +2779,7 @@
     </p:spTree>
     <p:extLst>
       <p:ext uri="{BB962C8B-B14F-4D97-AF65-F5344CB8AC3E}">
-        <p14:creationId xmlns:p14="http://schemas.microsoft.com/office/powerpoint/2010/main" val="1339463853"/>
+        <p14:creationId xmlns:p14="http://schemas.microsoft.com/office/powerpoint/2010/main" val="1118894970"/>
       </p:ext>
     </p:extLst>
   </p:cSld>
@@ -2810,7 +2810,7 @@
           <p:cNvPr id="17" name="Slide-Number-Placeholder-3-2">
             <a:extLst xmlns:a="http://schemas.openxmlformats.org/drawingml/2006/main">
               <a:ext uri="{FF2B5EF4-FFF2-40B4-BE49-F238E27FC236}">
-                <a16:creationId xmlns:a16="http://schemas.microsoft.com/office/drawing/2014/main" id="{36F8DD93-F1BA-4824-A14E-8FA40FC8100C}"/>
+                <a16:creationId xmlns:a16="http://schemas.microsoft.com/office/drawing/2014/main" id="{7E532AA7-C65B-4BA8-BBDD-66F24AA0876B}"/>
               </a:ext>
             </a:extLst>
           </p:cNvPr>
@@ -2853,7 +2853,7 @@
           <p:cNvPr id="2" name="Title-10-3">
             <a:extLst xmlns:a="http://schemas.openxmlformats.org/drawingml/2006/main">
               <a:ext uri="{FF2B5EF4-FFF2-40B4-BE49-F238E27FC236}">
-                <a16:creationId xmlns:a16="http://schemas.microsoft.com/office/drawing/2014/main" id="{FA476364-6482-40E9-8600-2AF8E9358C70}"/>
+                <a16:creationId xmlns:a16="http://schemas.microsoft.com/office/drawing/2014/main" id="{189E5873-C603-4868-9C7A-76D9A540C17B}"/>
               </a:ext>
             </a:extLst>
           </p:cNvPr>
@@ -2932,7 +2932,7 @@
           <p:cNvPr id="4" name="Google-Shape-2260-p159-5">
             <a:extLst xmlns:a="http://schemas.openxmlformats.org/drawingml/2006/main">
               <a:ext uri="{FF2B5EF4-FFF2-40B4-BE49-F238E27FC236}">
-                <a16:creationId xmlns:a16="http://schemas.microsoft.com/office/drawing/2014/main" id="{493E20C1-C5AE-4122-8510-8A070F41FBCB}"/>
+                <a16:creationId xmlns:a16="http://schemas.microsoft.com/office/drawing/2014/main" id="{57685B59-89FD-4197-A86E-D375016B9D7D}"/>
               </a:ext>
             </a:extLst>
           </p:cNvPr>
@@ -2959,7 +2959,7 @@
           <p:cNvPr id="5" name="Google-Shape-2261-p159-6">
             <a:extLst xmlns:a="http://schemas.openxmlformats.org/drawingml/2006/main">
               <a:ext uri="{FF2B5EF4-FFF2-40B4-BE49-F238E27FC236}">
-                <a16:creationId xmlns:a16="http://schemas.microsoft.com/office/drawing/2014/main" id="{08FFE0C7-2702-4676-89D9-27F36CE67980}"/>
+                <a16:creationId xmlns:a16="http://schemas.microsoft.com/office/drawing/2014/main" id="{114F2847-65A8-45B5-BA5C-A0EA1FEE578F}"/>
               </a:ext>
             </a:extLst>
           </p:cNvPr>
@@ -2986,7 +2986,7 @@
           <p:cNvPr id="6" name="Google-Shape-2262-p159-7">
             <a:extLst xmlns:a="http://schemas.openxmlformats.org/drawingml/2006/main">
               <a:ext uri="{FF2B5EF4-FFF2-40B4-BE49-F238E27FC236}">
-                <a16:creationId xmlns:a16="http://schemas.microsoft.com/office/drawing/2014/main" id="{62AA075F-7FEB-4E49-B793-750C873FEE10}"/>
+                <a16:creationId xmlns:a16="http://schemas.microsoft.com/office/drawing/2014/main" id="{9F88EC9B-45E0-4062-8906-B69ADB30E6AF}"/>
               </a:ext>
             </a:extLst>
           </p:cNvPr>
@@ -3013,7 +3013,7 @@
           <p:cNvPr id="7" name="Content-Placeholder-15-8">
             <a:extLst xmlns:a="http://schemas.openxmlformats.org/drawingml/2006/main">
               <a:ext uri="{FF2B5EF4-FFF2-40B4-BE49-F238E27FC236}">
-                <a16:creationId xmlns:a16="http://schemas.microsoft.com/office/drawing/2014/main" id="{9100B5D4-71C4-4394-99DA-46852FC9F5E8}"/>
+                <a16:creationId xmlns:a16="http://schemas.microsoft.com/office/drawing/2014/main" id="{C1E9563E-E618-47B2-93F0-4643C383E338}"/>
               </a:ext>
             </a:extLst>
           </p:cNvPr>
@@ -3070,7 +3070,7 @@
           <p:cNvPr id="8" name="Content-Placeholder-15-9">
             <a:extLst xmlns:a="http://schemas.openxmlformats.org/drawingml/2006/main">
               <a:ext uri="{FF2B5EF4-FFF2-40B4-BE49-F238E27FC236}">
-                <a16:creationId xmlns:a16="http://schemas.microsoft.com/office/drawing/2014/main" id="{927F374C-412E-42A0-A799-24F5BE98F5D2}"/>
+                <a16:creationId xmlns:a16="http://schemas.microsoft.com/office/drawing/2014/main" id="{F8070CD8-201D-4E78-B224-36FC9B97D2B9}"/>
               </a:ext>
             </a:extLst>
           </p:cNvPr>
@@ -3127,7 +3127,7 @@
           <p:cNvPr id="9" name="Content-Placeholder-15-10">
             <a:extLst xmlns:a="http://schemas.openxmlformats.org/drawingml/2006/main">
               <a:ext uri="{FF2B5EF4-FFF2-40B4-BE49-F238E27FC236}">
-                <a16:creationId xmlns:a16="http://schemas.microsoft.com/office/drawing/2014/main" id="{F13C6049-9E23-4B15-85C1-63B683C8E45F}"/>
+                <a16:creationId xmlns:a16="http://schemas.microsoft.com/office/drawing/2014/main" id="{842B849F-5888-4851-BE9B-655CE7C1F332}"/>
               </a:ext>
             </a:extLst>
           </p:cNvPr>
@@ -3184,7 +3184,7 @@
           <p:cNvPr id="10" name="Text-Placeholder-16-11">
             <a:extLst xmlns:a="http://schemas.openxmlformats.org/drawingml/2006/main">
               <a:ext uri="{FF2B5EF4-FFF2-40B4-BE49-F238E27FC236}">
-                <a16:creationId xmlns:a16="http://schemas.microsoft.com/office/drawing/2014/main" id="{0C5D656B-0BA3-4117-8FAB-72ECCA0478D7}"/>
+                <a16:creationId xmlns:a16="http://schemas.microsoft.com/office/drawing/2014/main" id="{1F5FEB6F-8713-41F4-AEA8-C103DCF54283}"/>
               </a:ext>
             </a:extLst>
           </p:cNvPr>
@@ -3268,7 +3268,7 @@
           <p:cNvPr id="11" name="Text-Placeholder-16-12">
             <a:extLst xmlns:a="http://schemas.openxmlformats.org/drawingml/2006/main">
               <a:ext uri="{FF2B5EF4-FFF2-40B4-BE49-F238E27FC236}">
-                <a16:creationId xmlns:a16="http://schemas.microsoft.com/office/drawing/2014/main" id="{0C632155-1372-40FF-881A-2472A8AB97F1}"/>
+                <a16:creationId xmlns:a16="http://schemas.microsoft.com/office/drawing/2014/main" id="{CAAAC04D-4310-45E8-95A1-9A093EED0BCA}"/>
               </a:ext>
             </a:extLst>
           </p:cNvPr>
@@ -3352,7 +3352,7 @@
           <p:cNvPr id="12" name="Text-Placeholder-16-13">
             <a:extLst xmlns:a="http://schemas.openxmlformats.org/drawingml/2006/main">
               <a:ext uri="{FF2B5EF4-FFF2-40B4-BE49-F238E27FC236}">
-                <a16:creationId xmlns:a16="http://schemas.microsoft.com/office/drawing/2014/main" id="{DBA510B0-F924-4F38-BB5D-7210153501F1}"/>
+                <a16:creationId xmlns:a16="http://schemas.microsoft.com/office/drawing/2014/main" id="{F8D24EDA-DC9F-42CA-972E-86826E7973BA}"/>
               </a:ext>
             </a:extLst>
           </p:cNvPr>
@@ -3436,7 +3436,7 @@
           <p:cNvPr id="13" name="accent-3">
             <a:extLst xmlns:a="http://schemas.openxmlformats.org/drawingml/2006/main">
               <a:ext uri="{FF2B5EF4-FFF2-40B4-BE49-F238E27FC236}">
-                <a16:creationId xmlns:a16="http://schemas.microsoft.com/office/drawing/2014/main" id="{C5F4CABA-BADD-4BB6-BA9A-654BA388E56C}"/>
+                <a16:creationId xmlns:a16="http://schemas.microsoft.com/office/drawing/2014/main" id="{4A05F372-9B24-4400-B82C-A1A8014264F6}"/>
               </a:ext>
             </a:extLst>
           </p:cNvPr>
@@ -3469,7 +3469,7 @@
           <p:cNvPr id="14" name="stage-01">
             <a:extLst xmlns:a="http://schemas.openxmlformats.org/drawingml/2006/main">
               <a:ext uri="{FF2B5EF4-FFF2-40B4-BE49-F238E27FC236}">
-                <a16:creationId xmlns:a16="http://schemas.microsoft.com/office/drawing/2014/main" id="{B0E85AA2-EB22-4701-B5FC-EDE8DF1D275A}"/>
+                <a16:creationId xmlns:a16="http://schemas.microsoft.com/office/drawing/2014/main" id="{CE0DC271-715A-4678-9689-A6AA713C3C13}"/>
               </a:ext>
             </a:extLst>
           </p:cNvPr>
@@ -3525,7 +3525,7 @@
           <p:cNvPr id="15" name="stage-02">
             <a:extLst xmlns:a="http://schemas.openxmlformats.org/drawingml/2006/main">
               <a:ext uri="{FF2B5EF4-FFF2-40B4-BE49-F238E27FC236}">
-                <a16:creationId xmlns:a16="http://schemas.microsoft.com/office/drawing/2014/main" id="{0342B077-D07C-43E6-9B54-36322E3BD3C6}"/>
+                <a16:creationId xmlns:a16="http://schemas.microsoft.com/office/drawing/2014/main" id="{FCEBC89E-E452-4CA6-AB4D-126DC8B0A636}"/>
               </a:ext>
             </a:extLst>
           </p:cNvPr>
@@ -3581,7 +3581,7 @@
           <p:cNvPr id="16" name="stage-03">
             <a:extLst xmlns:a="http://schemas.openxmlformats.org/drawingml/2006/main">
               <a:ext uri="{FF2B5EF4-FFF2-40B4-BE49-F238E27FC236}">
-                <a16:creationId xmlns:a16="http://schemas.microsoft.com/office/drawing/2014/main" id="{20D7080C-60CA-4EF7-8A11-A0020234117F}"/>
+                <a16:creationId xmlns:a16="http://schemas.microsoft.com/office/drawing/2014/main" id="{33ADEF4B-37C8-4EBF-997E-F29870D86399}"/>
               </a:ext>
             </a:extLst>
           </p:cNvPr>
@@ -3635,7 +3635,7 @@
     </p:spTree>
     <p:extLst>
       <p:ext uri="{BB962C8B-B14F-4D97-AF65-F5344CB8AC3E}">
-        <p14:creationId xmlns:p14="http://schemas.microsoft.com/office/powerpoint/2010/main" val="320745109"/>
+        <p14:creationId xmlns:p14="http://schemas.microsoft.com/office/powerpoint/2010/main" val="2096960865"/>
       </p:ext>
     </p:extLst>
   </p:cSld>
@@ -3666,7 +3666,7 @@
           <p:cNvPr id="7" name="accent-4">
             <a:extLst xmlns:a="http://schemas.openxmlformats.org/drawingml/2006/main">
               <a:ext uri="{FF2B5EF4-FFF2-40B4-BE49-F238E27FC236}">
-                <a16:creationId xmlns:a16="http://schemas.microsoft.com/office/drawing/2014/main" id="{EDC4A710-07FC-45BA-8C35-6628F6C94CA3}"/>
+                <a16:creationId xmlns:a16="http://schemas.microsoft.com/office/drawing/2014/main" id="{3D65D927-D365-482B-A822-D5B4A667E3AD}"/>
               </a:ext>
             </a:extLst>
           </p:cNvPr>
@@ -3699,7 +3699,7 @@
           <p:cNvPr id="2" name="safety-title">
             <a:extLst xmlns:a="http://schemas.openxmlformats.org/drawingml/2006/main">
               <a:ext uri="{FF2B5EF4-FFF2-40B4-BE49-F238E27FC236}">
-                <a16:creationId xmlns:a16="http://schemas.microsoft.com/office/drawing/2014/main" id="{CA999167-34EE-4F33-9B54-08CD3DF22C86}"/>
+                <a16:creationId xmlns:a16="http://schemas.microsoft.com/office/drawing/2014/main" id="{6EE9E39B-FEFA-4D43-94C5-AA4DAFB5D736}"/>
               </a:ext>
             </a:extLst>
           </p:cNvPr>
@@ -3755,7 +3755,7 @@
           <p:cNvPr id="3" name="safety-body">
             <a:extLst xmlns:a="http://schemas.openxmlformats.org/drawingml/2006/main">
               <a:ext uri="{FF2B5EF4-FFF2-40B4-BE49-F238E27FC236}">
-                <a16:creationId xmlns:a16="http://schemas.microsoft.com/office/drawing/2014/main" id="{90FBE412-ABAF-4BDD-81EF-0DCE3D35AFF5}"/>
+                <a16:creationId xmlns:a16="http://schemas.microsoft.com/office/drawing/2014/main" id="{669E76EB-3C76-4419-9F6C-7EC4B24C5569}"/>
               </a:ext>
             </a:extLst>
           </p:cNvPr>
@@ -3869,7 +3869,7 @@
           <p:cNvPr id="4" name="safety-callout">
             <a:extLst xmlns:a="http://schemas.openxmlformats.org/drawingml/2006/main">
               <a:ext uri="{FF2B5EF4-FFF2-40B4-BE49-F238E27FC236}">
-                <a16:creationId xmlns:a16="http://schemas.microsoft.com/office/drawing/2014/main" id="{614CF307-5A00-412C-B275-FABFF45BF6AD}"/>
+                <a16:creationId xmlns:a16="http://schemas.microsoft.com/office/drawing/2014/main" id="{7F5194F4-F145-4B99-95B6-6681E130BFFE}"/>
               </a:ext>
             </a:extLst>
           </p:cNvPr>
@@ -3929,7 +3929,7 @@
           <p:nvPr/>
         </p:nvPicPr>
         <p:blipFill>
-          <a:blip xmlns:r="http://schemas.openxmlformats.org/officeDocument/2006/relationships" xmlns:a="http://schemas.openxmlformats.org/drawingml/2006/main" r:embed="R7fabcb14ee4b4702"/>
+          <a:blip xmlns:r="http://schemas.openxmlformats.org/officeDocument/2006/relationships" xmlns:a="http://schemas.openxmlformats.org/drawingml/2006/main" r:embed="R1239a92e4eab4183"/>
           <a:stretch xmlns:a="http://schemas.openxmlformats.org/drawingml/2006/main"/>
         </p:blipFill>
         <p:spPr>
@@ -3949,7 +3949,7 @@
           <p:cNvPr id="6" name="screenshot-caption">
             <a:extLst xmlns:a="http://schemas.openxmlformats.org/drawingml/2006/main">
               <a:ext uri="{FF2B5EF4-FFF2-40B4-BE49-F238E27FC236}">
-                <a16:creationId xmlns:a16="http://schemas.microsoft.com/office/drawing/2014/main" id="{10817186-26D0-44E3-827C-C778AF304D74}"/>
+                <a16:creationId xmlns:a16="http://schemas.microsoft.com/office/drawing/2014/main" id="{0F7D7CAC-C705-48FC-8A0E-3E777A1FB454}"/>
               </a:ext>
             </a:extLst>
           </p:cNvPr>
@@ -3997,7 +3997,7 @@
     </p:spTree>
     <p:extLst>
       <p:ext uri="{BB962C8B-B14F-4D97-AF65-F5344CB8AC3E}">
-        <p14:creationId xmlns:p14="http://schemas.microsoft.com/office/powerpoint/2010/main" val="378497684"/>
+        <p14:creationId xmlns:p14="http://schemas.microsoft.com/office/powerpoint/2010/main" val="1557940164"/>
       </p:ext>
     </p:extLst>
   </p:cSld>
@@ -4028,7 +4028,7 @@
           <p:cNvPr id="14" name="Rounded-Rectangle-5-1">
             <a:extLst xmlns:a="http://schemas.openxmlformats.org/drawingml/2006/main">
               <a:ext uri="{FF2B5EF4-FFF2-40B4-BE49-F238E27FC236}">
-                <a16:creationId xmlns:a16="http://schemas.microsoft.com/office/drawing/2014/main" id="{B11A80D9-103A-4B98-8FCE-6653118A840F}"/>
+                <a16:creationId xmlns:a16="http://schemas.microsoft.com/office/drawing/2014/main" id="{32127819-3FA9-4867-869D-71300057B793}"/>
               </a:ext>
             </a:extLst>
           </p:cNvPr>
@@ -4057,7 +4057,7 @@
           <p:cNvPr id="2" name="Rounded-Rectangle-6-2">
             <a:extLst xmlns:a="http://schemas.openxmlformats.org/drawingml/2006/main">
               <a:ext uri="{FF2B5EF4-FFF2-40B4-BE49-F238E27FC236}">
-                <a16:creationId xmlns:a16="http://schemas.microsoft.com/office/drawing/2014/main" id="{AC9EED2E-3C3A-4ABF-B63D-6A0893E6A693}"/>
+                <a16:creationId xmlns:a16="http://schemas.microsoft.com/office/drawing/2014/main" id="{C19031F9-9A55-468A-BC4F-D3EAC9C0B61C}"/>
               </a:ext>
             </a:extLst>
           </p:cNvPr>
@@ -4086,7 +4086,7 @@
           <p:cNvPr id="3" name="Rounded-Rectangle-7-3">
             <a:extLst xmlns:a="http://schemas.openxmlformats.org/drawingml/2006/main">
               <a:ext uri="{FF2B5EF4-FFF2-40B4-BE49-F238E27FC236}">
-                <a16:creationId xmlns:a16="http://schemas.microsoft.com/office/drawing/2014/main" id="{867CF6CC-4659-45E9-BB89-9B8840F83ACF}"/>
+                <a16:creationId xmlns:a16="http://schemas.microsoft.com/office/drawing/2014/main" id="{E0917E1E-1178-4793-AC59-BC73EFC8C452}"/>
               </a:ext>
             </a:extLst>
           </p:cNvPr>
@@ -4115,7 +4115,7 @@
           <p:cNvPr id="4" name="Slide-Number-Placeholder-1-4">
             <a:extLst xmlns:a="http://schemas.openxmlformats.org/drawingml/2006/main">
               <a:ext uri="{FF2B5EF4-FFF2-40B4-BE49-F238E27FC236}">
-                <a16:creationId xmlns:a16="http://schemas.microsoft.com/office/drawing/2014/main" id="{C14232A7-2CF0-47CD-AA76-FB793B114F67}"/>
+                <a16:creationId xmlns:a16="http://schemas.microsoft.com/office/drawing/2014/main" id="{EF0BD66B-437F-4BCA-BEC6-1CB17F4EA2B9}"/>
               </a:ext>
             </a:extLst>
           </p:cNvPr>
@@ -4158,7 +4158,7 @@
           <p:cNvPr id="5" name="Title-2-5">
             <a:extLst xmlns:a="http://schemas.openxmlformats.org/drawingml/2006/main">
               <a:ext uri="{FF2B5EF4-FFF2-40B4-BE49-F238E27FC236}">
-                <a16:creationId xmlns:a16="http://schemas.microsoft.com/office/drawing/2014/main" id="{7197AF82-80BB-4F7C-8828-B6BA3C4CFC1C}"/>
+                <a16:creationId xmlns:a16="http://schemas.microsoft.com/office/drawing/2014/main" id="{1A4E3BB9-8140-4581-A3C2-591A2DCAB1BD}"/>
               </a:ext>
             </a:extLst>
           </p:cNvPr>
@@ -4215,7 +4215,7 @@
           <p:cNvPr id="6" name="Content-Placeholder-9-6">
             <a:extLst xmlns:a="http://schemas.openxmlformats.org/drawingml/2006/main">
               <a:ext uri="{FF2B5EF4-FFF2-40B4-BE49-F238E27FC236}">
-                <a16:creationId xmlns:a16="http://schemas.microsoft.com/office/drawing/2014/main" id="{4E99E291-63B5-4B36-805C-68339CF7462F}"/>
+                <a16:creationId xmlns:a16="http://schemas.microsoft.com/office/drawing/2014/main" id="{57EE3070-80B1-4982-AB3E-8D29D99E37A9}"/>
               </a:ext>
             </a:extLst>
           </p:cNvPr>
@@ -4272,7 +4272,7 @@
           <p:cNvPr id="7" name="Content-Placeholder-10-7">
             <a:extLst xmlns:a="http://schemas.openxmlformats.org/drawingml/2006/main">
               <a:ext uri="{FF2B5EF4-FFF2-40B4-BE49-F238E27FC236}">
-                <a16:creationId xmlns:a16="http://schemas.microsoft.com/office/drawing/2014/main" id="{ADB34FA8-D52C-4A3D-9369-9ECFF5EF30D1}"/>
+                <a16:creationId xmlns:a16="http://schemas.microsoft.com/office/drawing/2014/main" id="{1ACB4279-4C94-4DA6-BAB7-BBFE8CD43F76}"/>
               </a:ext>
             </a:extLst>
           </p:cNvPr>
@@ -4329,7 +4329,7 @@
           <p:cNvPr id="8" name="Content-Placeholder-11-8">
             <a:extLst xmlns:a="http://schemas.openxmlformats.org/drawingml/2006/main">
               <a:ext uri="{FF2B5EF4-FFF2-40B4-BE49-F238E27FC236}">
-                <a16:creationId xmlns:a16="http://schemas.microsoft.com/office/drawing/2014/main" id="{F0A89E69-8650-4B95-9A04-7A9E61DD503E}"/>
+                <a16:creationId xmlns:a16="http://schemas.microsoft.com/office/drawing/2014/main" id="{ECFD7965-B595-40AC-B06D-005875FE54F8}"/>
               </a:ext>
             </a:extLst>
           </p:cNvPr>
@@ -4386,7 +4386,7 @@
           <p:cNvPr id="9" name="Content-Placeholder-9-9">
             <a:extLst xmlns:a="http://schemas.openxmlformats.org/drawingml/2006/main">
               <a:ext uri="{FF2B5EF4-FFF2-40B4-BE49-F238E27FC236}">
-                <a16:creationId xmlns:a16="http://schemas.microsoft.com/office/drawing/2014/main" id="{401CA637-3749-4D78-9EBB-069C3F5D489E}"/>
+                <a16:creationId xmlns:a16="http://schemas.microsoft.com/office/drawing/2014/main" id="{EE5C697A-9600-46C1-ABCE-1F28FC01C373}"/>
               </a:ext>
             </a:extLst>
           </p:cNvPr>
@@ -4433,7 +4433,7 @@
                 <a:ea typeface="Aptos"/>
                 <a:cs typeface="Aptos"/>
               </a:rPr>
-              <a:t>27 / 27</a:t>
+              <a:t>28 / 28</a:t>
             </a:r>
           </a:p>
         </p:txBody>
@@ -4443,7 +4443,7 @@
           <p:cNvPr id="10" name="Content-Placeholder-9-10">
             <a:extLst xmlns:a="http://schemas.openxmlformats.org/drawingml/2006/main">
               <a:ext uri="{FF2B5EF4-FFF2-40B4-BE49-F238E27FC236}">
-                <a16:creationId xmlns:a16="http://schemas.microsoft.com/office/drawing/2014/main" id="{57CAD8B0-21F0-4088-B197-61CE434D2424}"/>
+                <a16:creationId xmlns:a16="http://schemas.microsoft.com/office/drawing/2014/main" id="{9AE5AD8E-BAB1-4299-8CAB-F136D71D134E}"/>
               </a:ext>
             </a:extLst>
           </p:cNvPr>
@@ -4500,7 +4500,7 @@
           <p:cNvPr id="11" name="Content-Placeholder-9-11">
             <a:extLst xmlns:a="http://schemas.openxmlformats.org/drawingml/2006/main">
               <a:ext uri="{FF2B5EF4-FFF2-40B4-BE49-F238E27FC236}">
-                <a16:creationId xmlns:a16="http://schemas.microsoft.com/office/drawing/2014/main" id="{C4E90B6F-B4BE-4FA7-A19E-A755E498F941}"/>
+                <a16:creationId xmlns:a16="http://schemas.microsoft.com/office/drawing/2014/main" id="{749C7069-72DF-485A-A7A3-A325885B8AEC}"/>
               </a:ext>
             </a:extLst>
           </p:cNvPr>
@@ -4557,7 +4557,7 @@
           <p:cNvPr id="12" name="Content-Placeholder-15-12">
             <a:extLst xmlns:a="http://schemas.openxmlformats.org/drawingml/2006/main">
               <a:ext uri="{FF2B5EF4-FFF2-40B4-BE49-F238E27FC236}">
-                <a16:creationId xmlns:a16="http://schemas.microsoft.com/office/drawing/2014/main" id="{20095E69-E410-46F1-821E-8E32215E53E3}"/>
+                <a16:creationId xmlns:a16="http://schemas.microsoft.com/office/drawing/2014/main" id="{0AC455EA-DEAB-45D0-B0B3-042E5DB3CE60}"/>
               </a:ext>
             </a:extLst>
           </p:cNvPr>
@@ -4641,7 +4641,7 @@
           <p:cNvPr id="13" name="accent-5">
             <a:extLst xmlns:a="http://schemas.openxmlformats.org/drawingml/2006/main">
               <a:ext uri="{FF2B5EF4-FFF2-40B4-BE49-F238E27FC236}">
-                <a16:creationId xmlns:a16="http://schemas.microsoft.com/office/drawing/2014/main" id="{EB87DA61-EE46-4302-A023-A15BA5A4A24A}"/>
+                <a16:creationId xmlns:a16="http://schemas.microsoft.com/office/drawing/2014/main" id="{1C72FC4F-4E5A-4320-8A26-542375A5E229}"/>
               </a:ext>
             </a:extLst>
           </p:cNvPr>
@@ -4672,7 +4672,7 @@
     </p:spTree>
     <p:extLst>
       <p:ext uri="{BB962C8B-B14F-4D97-AF65-F5344CB8AC3E}">
-        <p14:creationId xmlns:p14="http://schemas.microsoft.com/office/powerpoint/2010/main" val="1576527280"/>
+        <p14:creationId xmlns:p14="http://schemas.microsoft.com/office/powerpoint/2010/main" val="1849818267"/>
       </p:ext>
     </p:extLst>
   </p:cSld>
@@ -4703,7 +4703,7 @@
           <p:cNvPr id="5" name="Title-3-1">
             <a:extLst xmlns:a="http://schemas.openxmlformats.org/drawingml/2006/main">
               <a:ext uri="{FF2B5EF4-FFF2-40B4-BE49-F238E27FC236}">
-                <a16:creationId xmlns:a16="http://schemas.microsoft.com/office/drawing/2014/main" id="{2B559A25-855B-4BFD-BEB1-3C0A86F8C298}"/>
+                <a16:creationId xmlns:a16="http://schemas.microsoft.com/office/drawing/2014/main" id="{FE98BA7B-8F4F-4F73-B563-4FE2DB8C967C}"/>
               </a:ext>
             </a:extLst>
           </p:cNvPr>
@@ -4760,7 +4760,7 @@
           <p:cNvPr id="2" name="Subtitle-4-2">
             <a:extLst xmlns:a="http://schemas.openxmlformats.org/drawingml/2006/main">
               <a:ext uri="{FF2B5EF4-FFF2-40B4-BE49-F238E27FC236}">
-                <a16:creationId xmlns:a16="http://schemas.microsoft.com/office/drawing/2014/main" id="{18425392-D691-4FCC-B946-87D9EC2BC9B4}"/>
+                <a16:creationId xmlns:a16="http://schemas.microsoft.com/office/drawing/2014/main" id="{18779017-783C-4BBE-B8D4-6A57745B6B07}"/>
               </a:ext>
             </a:extLst>
           </p:cNvPr>
@@ -4871,7 +4871,7 @@
           <p:cNvPr id="3" name="Subtitle-4-3">
             <a:extLst xmlns:a="http://schemas.openxmlformats.org/drawingml/2006/main">
               <a:ext uri="{FF2B5EF4-FFF2-40B4-BE49-F238E27FC236}">
-                <a16:creationId xmlns:a16="http://schemas.microsoft.com/office/drawing/2014/main" id="{2E985C1D-A930-4A53-8E89-09B120FE7A7D}"/>
+                <a16:creationId xmlns:a16="http://schemas.microsoft.com/office/drawing/2014/main" id="{BC4B3B3F-170B-4B45-A518-45618D8B04DE}"/>
               </a:ext>
             </a:extLst>
           </p:cNvPr>
@@ -4928,7 +4928,7 @@
           <p:cNvPr id="4" name="accent-6">
             <a:extLst xmlns:a="http://schemas.openxmlformats.org/drawingml/2006/main">
               <a:ext uri="{FF2B5EF4-FFF2-40B4-BE49-F238E27FC236}">
-                <a16:creationId xmlns:a16="http://schemas.microsoft.com/office/drawing/2014/main" id="{CD3C0387-D9BC-46E1-B931-A8315CB10813}"/>
+                <a16:creationId xmlns:a16="http://schemas.microsoft.com/office/drawing/2014/main" id="{21A3EB85-A845-497D-8127-15A8294E6BF3}"/>
               </a:ext>
             </a:extLst>
           </p:cNvPr>
@@ -4959,7 +4959,7 @@
     </p:spTree>
     <p:extLst>
       <p:ext uri="{BB962C8B-B14F-4D97-AF65-F5344CB8AC3E}">
-        <p14:creationId xmlns:p14="http://schemas.microsoft.com/office/powerpoint/2010/main" val="1660388434"/>
+        <p14:creationId xmlns:p14="http://schemas.microsoft.com/office/powerpoint/2010/main" val="89077359"/>
       </p:ext>
     </p:extLst>
   </p:cSld>

</xml_diff>

<commit_message>
Document final verification results
</commit_message>
<xml_diff>
--- a/docs/FaultTrace_5_Minute_Presentation.pptx
+++ b/docs/FaultTrace_5_Minute_Presentation.pptx
@@ -2,18 +2,18 @@
 <file path=ppt/presentation.xml><?xml version="1.0" encoding="utf-8"?>
 <p:presentation xmlns:p="http://schemas.openxmlformats.org/presentationml/2006/main">
   <p:sldMasterIdLst>
-    <p:sldMasterId xmlns:r="http://schemas.openxmlformats.org/officeDocument/2006/relationships" id="2147483648" r:id="R60907a2ecdfc4d68"/>
+    <p:sldMasterId xmlns:r="http://schemas.openxmlformats.org/officeDocument/2006/relationships" id="2147483648" r:id="R25c2a8cc562843b2"/>
   </p:sldMasterIdLst>
   <p:notesMasterIdLst>
-    <p:notesMasterId xmlns:r="http://schemas.openxmlformats.org/officeDocument/2006/relationships" r:id="R12980f1cc19841d9"/>
+    <p:notesMasterId xmlns:r="http://schemas.openxmlformats.org/officeDocument/2006/relationships" r:id="R066b1c365a9d4c81"/>
   </p:notesMasterIdLst>
   <p:sldIdLst>
-    <p:sldId xmlns:r="http://schemas.openxmlformats.org/officeDocument/2006/relationships" id="256" r:id="Rf79ae55c2fe745cf"/>
-    <p:sldId xmlns:r="http://schemas.openxmlformats.org/officeDocument/2006/relationships" id="257" r:id="R43bedd9ba29e4288"/>
-    <p:sldId xmlns:r="http://schemas.openxmlformats.org/officeDocument/2006/relationships" id="258" r:id="R300981bfbf334ba9"/>
-    <p:sldId xmlns:r="http://schemas.openxmlformats.org/officeDocument/2006/relationships" id="259" r:id="R286e4e244fae407a"/>
-    <p:sldId xmlns:r="http://schemas.openxmlformats.org/officeDocument/2006/relationships" id="260" r:id="R832ded7f4f034b8c"/>
-    <p:sldId xmlns:r="http://schemas.openxmlformats.org/officeDocument/2006/relationships" id="261" r:id="R0d205b47a8304fa9"/>
+    <p:sldId xmlns:r="http://schemas.openxmlformats.org/officeDocument/2006/relationships" id="256" r:id="R131f702a4271434c"/>
+    <p:sldId xmlns:r="http://schemas.openxmlformats.org/officeDocument/2006/relationships" id="257" r:id="R54529e71af0b402e"/>
+    <p:sldId xmlns:r="http://schemas.openxmlformats.org/officeDocument/2006/relationships" id="258" r:id="Rdbef52b1b0484b22"/>
+    <p:sldId xmlns:r="http://schemas.openxmlformats.org/officeDocument/2006/relationships" id="259" r:id="R2b7702c47a0a4c78"/>
+    <p:sldId xmlns:r="http://schemas.openxmlformats.org/officeDocument/2006/relationships" id="260" r:id="R5c209e7e1010491f"/>
+    <p:sldId xmlns:r="http://schemas.openxmlformats.org/officeDocument/2006/relationships" id="261" r:id="Ra0b540d367c14583"/>
   </p:sldIdLst>
   <p:sldSz cx="12192000" cy="6858000"/>
   <p:notesSz cx="6858000" cy="9144000"/>
@@ -1040,7 +1040,7 @@
   </p:cSld>
   <p:clrMap bg1="lt1" tx1="dk1" bg2="lt2" tx2="dk2" accent1="accent1" accent2="accent2" accent3="accent3" accent4="accent4" accent5="accent5" accent6="accent6" hlink="hlink" folHlink="folHlink"/>
   <p:sldLayoutIdLst>
-    <p:sldLayoutId xmlns:r="http://schemas.openxmlformats.org/officeDocument/2006/relationships" id="2147483649" r:id="R45b52882400c487c"/>
+    <p:sldLayoutId xmlns:r="http://schemas.openxmlformats.org/officeDocument/2006/relationships" id="2147483649" r:id="Rfeef0338e2d647b9"/>
   </p:sldLayoutIdLst>
   <p:txStyles>
     <p:titleStyle>
@@ -1591,7 +1591,7 @@
           <p:cNvPr id="5" name="Title-3-1">
             <a:extLst xmlns:a="http://schemas.openxmlformats.org/drawingml/2006/main">
               <a:ext uri="{FF2B5EF4-FFF2-40B4-BE49-F238E27FC236}">
-                <a16:creationId xmlns:a16="http://schemas.microsoft.com/office/drawing/2014/main" id="{DEB44865-5B40-4A66-8BA3-1DA3F4582A43}"/>
+                <a16:creationId xmlns:a16="http://schemas.microsoft.com/office/drawing/2014/main" id="{814372F2-ACAF-4AB3-A423-1C6F87D33133}"/>
               </a:ext>
             </a:extLst>
           </p:cNvPr>
@@ -1648,7 +1648,7 @@
           <p:cNvPr id="2" name="Subtitle-4-2">
             <a:extLst xmlns:a="http://schemas.openxmlformats.org/drawingml/2006/main">
               <a:ext uri="{FF2B5EF4-FFF2-40B4-BE49-F238E27FC236}">
-                <a16:creationId xmlns:a16="http://schemas.microsoft.com/office/drawing/2014/main" id="{12AD8436-767F-4879-A8B9-FA7899883E27}"/>
+                <a16:creationId xmlns:a16="http://schemas.microsoft.com/office/drawing/2014/main" id="{F585FAFF-BB93-4CEE-9D8C-0B220E5D4E2D}"/>
               </a:ext>
             </a:extLst>
           </p:cNvPr>
@@ -1705,7 +1705,7 @@
           <p:cNvPr id="3" name="Subtitle-4-3">
             <a:extLst xmlns:a="http://schemas.openxmlformats.org/drawingml/2006/main">
               <a:ext uri="{FF2B5EF4-FFF2-40B4-BE49-F238E27FC236}">
-                <a16:creationId xmlns:a16="http://schemas.microsoft.com/office/drawing/2014/main" id="{BBB58DDF-A5DA-4937-8AAD-3DA4565A4CE1}"/>
+                <a16:creationId xmlns:a16="http://schemas.microsoft.com/office/drawing/2014/main" id="{0C3998C8-9B79-4B61-8055-5871165885F5}"/>
               </a:ext>
             </a:extLst>
           </p:cNvPr>
@@ -1762,7 +1762,7 @@
           <p:cNvPr id="4" name="accent-1">
             <a:extLst xmlns:a="http://schemas.openxmlformats.org/drawingml/2006/main">
               <a:ext uri="{FF2B5EF4-FFF2-40B4-BE49-F238E27FC236}">
-                <a16:creationId xmlns:a16="http://schemas.microsoft.com/office/drawing/2014/main" id="{A9D6C8B6-82E8-4744-8FF7-26E4428252C4}"/>
+                <a16:creationId xmlns:a16="http://schemas.microsoft.com/office/drawing/2014/main" id="{6FB74210-B6AE-4C47-A6C9-57083237B785}"/>
               </a:ext>
             </a:extLst>
           </p:cNvPr>
@@ -1793,7 +1793,7 @@
     </p:spTree>
     <p:extLst>
       <p:ext uri="{BB962C8B-B14F-4D97-AF65-F5344CB8AC3E}">
-        <p14:creationId xmlns:p14="http://schemas.microsoft.com/office/powerpoint/2010/main" val="251773179"/>
+        <p14:creationId xmlns:p14="http://schemas.microsoft.com/office/powerpoint/2010/main" val="637750001"/>
       </p:ext>
     </p:extLst>
   </p:cSld>
@@ -1824,7 +1824,7 @@
           <p:cNvPr id="14" name="Google-Shape-532-p58-2">
             <a:extLst xmlns:a="http://schemas.openxmlformats.org/drawingml/2006/main">
               <a:ext uri="{FF2B5EF4-FFF2-40B4-BE49-F238E27FC236}">
-                <a16:creationId xmlns:a16="http://schemas.microsoft.com/office/drawing/2014/main" id="{E1E823D0-18EB-47D0-B5B0-AEF2A4D6CF84}"/>
+                <a16:creationId xmlns:a16="http://schemas.microsoft.com/office/drawing/2014/main" id="{0B676E61-541C-4252-A0A4-785695CC43D0}"/>
               </a:ext>
             </a:extLst>
           </p:cNvPr>
@@ -1869,7 +1869,7 @@
           <p:cNvPr id="2" name="Google-Shape-533-p58-3">
             <a:extLst xmlns:a="http://schemas.openxmlformats.org/drawingml/2006/main">
               <a:ext uri="{FF2B5EF4-FFF2-40B4-BE49-F238E27FC236}">
-                <a16:creationId xmlns:a16="http://schemas.microsoft.com/office/drawing/2014/main" id="{8B376E27-ED3A-4E43-93B3-DEC426B40C8A}"/>
+                <a16:creationId xmlns:a16="http://schemas.microsoft.com/office/drawing/2014/main" id="{96FE50BF-50A4-43BC-AC22-8A7A8576F2E2}"/>
               </a:ext>
             </a:extLst>
           </p:cNvPr>
@@ -1926,7 +1926,7 @@
           <p:cNvPr id="3" name="Rounded-Rectangle-9-4">
             <a:extLst xmlns:a="http://schemas.openxmlformats.org/drawingml/2006/main">
               <a:ext uri="{FF2B5EF4-FFF2-40B4-BE49-F238E27FC236}">
-                <a16:creationId xmlns:a16="http://schemas.microsoft.com/office/drawing/2014/main" id="{6BC1FC63-5861-4625-AB54-3A03E458813B}"/>
+                <a16:creationId xmlns:a16="http://schemas.microsoft.com/office/drawing/2014/main" id="{3F6D5530-15AC-47D7-87E3-CAF8DD1B9085}"/>
               </a:ext>
             </a:extLst>
           </p:cNvPr>
@@ -1955,7 +1955,7 @@
           <p:cNvPr id="4" name="Rounded-Rectangle-10-5">
             <a:extLst xmlns:a="http://schemas.openxmlformats.org/drawingml/2006/main">
               <a:ext uri="{FF2B5EF4-FFF2-40B4-BE49-F238E27FC236}">
-                <a16:creationId xmlns:a16="http://schemas.microsoft.com/office/drawing/2014/main" id="{400D25B8-C725-45BE-880D-4702BE7E042D}"/>
+                <a16:creationId xmlns:a16="http://schemas.microsoft.com/office/drawing/2014/main" id="{D0B9967B-E4B1-4FA0-B5F0-22167840384E}"/>
               </a:ext>
             </a:extLst>
           </p:cNvPr>
@@ -1984,7 +1984,7 @@
           <p:cNvPr id="5" name="Content-Placeholder-9-6">
             <a:extLst xmlns:a="http://schemas.openxmlformats.org/drawingml/2006/main">
               <a:ext uri="{FF2B5EF4-FFF2-40B4-BE49-F238E27FC236}">
-                <a16:creationId xmlns:a16="http://schemas.microsoft.com/office/drawing/2014/main" id="{352F32A0-75B8-4A0F-83DA-3D8BB7C610C3}"/>
+                <a16:creationId xmlns:a16="http://schemas.microsoft.com/office/drawing/2014/main" id="{69008C56-31AC-4C97-8C29-772CE3F7B070}"/>
               </a:ext>
             </a:extLst>
           </p:cNvPr>
@@ -2068,7 +2068,7 @@
           <p:cNvPr id="6" name="Content-Placeholder-10-7">
             <a:extLst xmlns:a="http://schemas.openxmlformats.org/drawingml/2006/main">
               <a:ext uri="{FF2B5EF4-FFF2-40B4-BE49-F238E27FC236}">
-                <a16:creationId xmlns:a16="http://schemas.microsoft.com/office/drawing/2014/main" id="{8D730748-3773-45CF-8BDB-66F3DC0A63DD}"/>
+                <a16:creationId xmlns:a16="http://schemas.microsoft.com/office/drawing/2014/main" id="{8857F46E-D7FC-417F-A028-07E00D87146E}"/>
               </a:ext>
             </a:extLst>
           </p:cNvPr>
@@ -2152,7 +2152,7 @@
           <p:cNvPr id="7" name="Google-Shape-340-p61-8">
             <a:extLst xmlns:a="http://schemas.openxmlformats.org/drawingml/2006/main">
               <a:ext uri="{FF2B5EF4-FFF2-40B4-BE49-F238E27FC236}">
-                <a16:creationId xmlns:a16="http://schemas.microsoft.com/office/drawing/2014/main" id="{8CC64178-4B7B-4BBC-8AA3-DBDF523C0BEF}"/>
+                <a16:creationId xmlns:a16="http://schemas.microsoft.com/office/drawing/2014/main" id="{1FFE4E5B-273F-4B0D-9DD9-CEFC8E2F83EF}"/>
               </a:ext>
             </a:extLst>
           </p:cNvPr>
@@ -2276,7 +2276,7 @@
           <p:cNvPr id="8" name="Google-Shape-340-p61-9">
             <a:extLst xmlns:a="http://schemas.openxmlformats.org/drawingml/2006/main">
               <a:ext uri="{FF2B5EF4-FFF2-40B4-BE49-F238E27FC236}">
-                <a16:creationId xmlns:a16="http://schemas.microsoft.com/office/drawing/2014/main" id="{17430167-6567-4676-ACCF-4BF2DD4FA3C8}"/>
+                <a16:creationId xmlns:a16="http://schemas.microsoft.com/office/drawing/2014/main" id="{E9794174-C369-4EBD-98C7-8BD80DD0C92D}"/>
               </a:ext>
             </a:extLst>
           </p:cNvPr>
@@ -2400,7 +2400,7 @@
           <p:cNvPr id="9" name="Rounded-Rectangle-5-10">
             <a:extLst xmlns:a="http://schemas.openxmlformats.org/drawingml/2006/main">
               <a:ext uri="{FF2B5EF4-FFF2-40B4-BE49-F238E27FC236}">
-                <a16:creationId xmlns:a16="http://schemas.microsoft.com/office/drawing/2014/main" id="{B1FFE009-6898-43DF-9C06-CFAF9CD344A8}"/>
+                <a16:creationId xmlns:a16="http://schemas.microsoft.com/office/drawing/2014/main" id="{CA528B17-01B0-46C2-968E-1502AB891606}"/>
               </a:ext>
             </a:extLst>
           </p:cNvPr>
@@ -2429,7 +2429,7 @@
           <p:cNvPr id="10" name="Content-Placeholder-9-11">
             <a:extLst xmlns:a="http://schemas.openxmlformats.org/drawingml/2006/main">
               <a:ext uri="{FF2B5EF4-FFF2-40B4-BE49-F238E27FC236}">
-                <a16:creationId xmlns:a16="http://schemas.microsoft.com/office/drawing/2014/main" id="{A8BA744C-A4CE-43AC-AB45-EC1CDDF2986C}"/>
+                <a16:creationId xmlns:a16="http://schemas.microsoft.com/office/drawing/2014/main" id="{D6702BD9-2917-4812-B387-FFDED57F2772}"/>
               </a:ext>
             </a:extLst>
           </p:cNvPr>
@@ -2513,7 +2513,7 @@
           <p:cNvPr id="11" name="Google-Shape-340-p61-12">
             <a:extLst xmlns:a="http://schemas.openxmlformats.org/drawingml/2006/main">
               <a:ext uri="{FF2B5EF4-FFF2-40B4-BE49-F238E27FC236}">
-                <a16:creationId xmlns:a16="http://schemas.microsoft.com/office/drawing/2014/main" id="{807687B0-FFCE-42D7-B90B-FF48B3F07063}"/>
+                <a16:creationId xmlns:a16="http://schemas.microsoft.com/office/drawing/2014/main" id="{19858CA6-197B-4E80-9A18-10DD19B1B686}"/>
               </a:ext>
             </a:extLst>
           </p:cNvPr>
@@ -2637,7 +2637,7 @@
           <p:cNvPr id="12" name="Content-Placeholder-15-13">
             <a:extLst xmlns:a="http://schemas.openxmlformats.org/drawingml/2006/main">
               <a:ext uri="{FF2B5EF4-FFF2-40B4-BE49-F238E27FC236}">
-                <a16:creationId xmlns:a16="http://schemas.microsoft.com/office/drawing/2014/main" id="{ECD6D0E1-D964-4065-A795-AA5FA7B93AEA}"/>
+                <a16:creationId xmlns:a16="http://schemas.microsoft.com/office/drawing/2014/main" id="{861CDA91-B88A-4E87-B89F-F37EB2DA0DAB}"/>
               </a:ext>
             </a:extLst>
           </p:cNvPr>
@@ -2748,7 +2748,7 @@
           <p:cNvPr id="13" name="accent-2">
             <a:extLst xmlns:a="http://schemas.openxmlformats.org/drawingml/2006/main">
               <a:ext uri="{FF2B5EF4-FFF2-40B4-BE49-F238E27FC236}">
-                <a16:creationId xmlns:a16="http://schemas.microsoft.com/office/drawing/2014/main" id="{74333901-449F-49A4-9D8B-2222C3171028}"/>
+                <a16:creationId xmlns:a16="http://schemas.microsoft.com/office/drawing/2014/main" id="{87531248-7062-4104-81DF-E382081FC233}"/>
               </a:ext>
             </a:extLst>
           </p:cNvPr>
@@ -2779,7 +2779,7 @@
     </p:spTree>
     <p:extLst>
       <p:ext uri="{BB962C8B-B14F-4D97-AF65-F5344CB8AC3E}">
-        <p14:creationId xmlns:p14="http://schemas.microsoft.com/office/powerpoint/2010/main" val="1118894970"/>
+        <p14:creationId xmlns:p14="http://schemas.microsoft.com/office/powerpoint/2010/main" val="1830899715"/>
       </p:ext>
     </p:extLst>
   </p:cSld>
@@ -2810,7 +2810,7 @@
           <p:cNvPr id="17" name="Slide-Number-Placeholder-3-2">
             <a:extLst xmlns:a="http://schemas.openxmlformats.org/drawingml/2006/main">
               <a:ext uri="{FF2B5EF4-FFF2-40B4-BE49-F238E27FC236}">
-                <a16:creationId xmlns:a16="http://schemas.microsoft.com/office/drawing/2014/main" id="{7E532AA7-C65B-4BA8-BBDD-66F24AA0876B}"/>
+                <a16:creationId xmlns:a16="http://schemas.microsoft.com/office/drawing/2014/main" id="{1BD76626-06FB-4D02-A206-3814EF99FC74}"/>
               </a:ext>
             </a:extLst>
           </p:cNvPr>
@@ -2853,7 +2853,7 @@
           <p:cNvPr id="2" name="Title-10-3">
             <a:extLst xmlns:a="http://schemas.openxmlformats.org/drawingml/2006/main">
               <a:ext uri="{FF2B5EF4-FFF2-40B4-BE49-F238E27FC236}">
-                <a16:creationId xmlns:a16="http://schemas.microsoft.com/office/drawing/2014/main" id="{189E5873-C603-4868-9C7A-76D9A540C17B}"/>
+                <a16:creationId xmlns:a16="http://schemas.microsoft.com/office/drawing/2014/main" id="{B7D1E2CC-4939-4827-8091-E744764F15EE}"/>
               </a:ext>
             </a:extLst>
           </p:cNvPr>
@@ -2932,7 +2932,7 @@
           <p:cNvPr id="4" name="Google-Shape-2260-p159-5">
             <a:extLst xmlns:a="http://schemas.openxmlformats.org/drawingml/2006/main">
               <a:ext uri="{FF2B5EF4-FFF2-40B4-BE49-F238E27FC236}">
-                <a16:creationId xmlns:a16="http://schemas.microsoft.com/office/drawing/2014/main" id="{57685B59-89FD-4197-A86E-D375016B9D7D}"/>
+                <a16:creationId xmlns:a16="http://schemas.microsoft.com/office/drawing/2014/main" id="{B28A7430-8C82-441B-98DF-1F6E2BEE834B}"/>
               </a:ext>
             </a:extLst>
           </p:cNvPr>
@@ -2959,7 +2959,7 @@
           <p:cNvPr id="5" name="Google-Shape-2261-p159-6">
             <a:extLst xmlns:a="http://schemas.openxmlformats.org/drawingml/2006/main">
               <a:ext uri="{FF2B5EF4-FFF2-40B4-BE49-F238E27FC236}">
-                <a16:creationId xmlns:a16="http://schemas.microsoft.com/office/drawing/2014/main" id="{114F2847-65A8-45B5-BA5C-A0EA1FEE578F}"/>
+                <a16:creationId xmlns:a16="http://schemas.microsoft.com/office/drawing/2014/main" id="{197F24FA-E134-47E4-AE91-032FF11E0752}"/>
               </a:ext>
             </a:extLst>
           </p:cNvPr>
@@ -2986,7 +2986,7 @@
           <p:cNvPr id="6" name="Google-Shape-2262-p159-7">
             <a:extLst xmlns:a="http://schemas.openxmlformats.org/drawingml/2006/main">
               <a:ext uri="{FF2B5EF4-FFF2-40B4-BE49-F238E27FC236}">
-                <a16:creationId xmlns:a16="http://schemas.microsoft.com/office/drawing/2014/main" id="{9F88EC9B-45E0-4062-8906-B69ADB30E6AF}"/>
+                <a16:creationId xmlns:a16="http://schemas.microsoft.com/office/drawing/2014/main" id="{3AD9CAAD-E5B3-4BAD-A340-839F6CF65886}"/>
               </a:ext>
             </a:extLst>
           </p:cNvPr>
@@ -3013,7 +3013,7 @@
           <p:cNvPr id="7" name="Content-Placeholder-15-8">
             <a:extLst xmlns:a="http://schemas.openxmlformats.org/drawingml/2006/main">
               <a:ext uri="{FF2B5EF4-FFF2-40B4-BE49-F238E27FC236}">
-                <a16:creationId xmlns:a16="http://schemas.microsoft.com/office/drawing/2014/main" id="{C1E9563E-E618-47B2-93F0-4643C383E338}"/>
+                <a16:creationId xmlns:a16="http://schemas.microsoft.com/office/drawing/2014/main" id="{66222880-B93A-4AA9-8362-ECD0EB3AEB88}"/>
               </a:ext>
             </a:extLst>
           </p:cNvPr>
@@ -3070,7 +3070,7 @@
           <p:cNvPr id="8" name="Content-Placeholder-15-9">
             <a:extLst xmlns:a="http://schemas.openxmlformats.org/drawingml/2006/main">
               <a:ext uri="{FF2B5EF4-FFF2-40B4-BE49-F238E27FC236}">
-                <a16:creationId xmlns:a16="http://schemas.microsoft.com/office/drawing/2014/main" id="{F8070CD8-201D-4E78-B224-36FC9B97D2B9}"/>
+                <a16:creationId xmlns:a16="http://schemas.microsoft.com/office/drawing/2014/main" id="{714255C6-926B-4F56-AE0F-EB3D095A795D}"/>
               </a:ext>
             </a:extLst>
           </p:cNvPr>
@@ -3127,7 +3127,7 @@
           <p:cNvPr id="9" name="Content-Placeholder-15-10">
             <a:extLst xmlns:a="http://schemas.openxmlformats.org/drawingml/2006/main">
               <a:ext uri="{FF2B5EF4-FFF2-40B4-BE49-F238E27FC236}">
-                <a16:creationId xmlns:a16="http://schemas.microsoft.com/office/drawing/2014/main" id="{842B849F-5888-4851-BE9B-655CE7C1F332}"/>
+                <a16:creationId xmlns:a16="http://schemas.microsoft.com/office/drawing/2014/main" id="{531E1EF5-3F3E-4D4F-B6DD-644823B7D389}"/>
               </a:ext>
             </a:extLst>
           </p:cNvPr>
@@ -3184,7 +3184,7 @@
           <p:cNvPr id="10" name="Text-Placeholder-16-11">
             <a:extLst xmlns:a="http://schemas.openxmlformats.org/drawingml/2006/main">
               <a:ext uri="{FF2B5EF4-FFF2-40B4-BE49-F238E27FC236}">
-                <a16:creationId xmlns:a16="http://schemas.microsoft.com/office/drawing/2014/main" id="{1F5FEB6F-8713-41F4-AEA8-C103DCF54283}"/>
+                <a16:creationId xmlns:a16="http://schemas.microsoft.com/office/drawing/2014/main" id="{3606AD44-9EFC-4CA0-B91A-F8E0BCF97960}"/>
               </a:ext>
             </a:extLst>
           </p:cNvPr>
@@ -3268,7 +3268,7 @@
           <p:cNvPr id="11" name="Text-Placeholder-16-12">
             <a:extLst xmlns:a="http://schemas.openxmlformats.org/drawingml/2006/main">
               <a:ext uri="{FF2B5EF4-FFF2-40B4-BE49-F238E27FC236}">
-                <a16:creationId xmlns:a16="http://schemas.microsoft.com/office/drawing/2014/main" id="{CAAAC04D-4310-45E8-95A1-9A093EED0BCA}"/>
+                <a16:creationId xmlns:a16="http://schemas.microsoft.com/office/drawing/2014/main" id="{1033C66D-7B3C-4A62-A01E-D83F5FCDE778}"/>
               </a:ext>
             </a:extLst>
           </p:cNvPr>
@@ -3352,7 +3352,7 @@
           <p:cNvPr id="12" name="Text-Placeholder-16-13">
             <a:extLst xmlns:a="http://schemas.openxmlformats.org/drawingml/2006/main">
               <a:ext uri="{FF2B5EF4-FFF2-40B4-BE49-F238E27FC236}">
-                <a16:creationId xmlns:a16="http://schemas.microsoft.com/office/drawing/2014/main" id="{F8D24EDA-DC9F-42CA-972E-86826E7973BA}"/>
+                <a16:creationId xmlns:a16="http://schemas.microsoft.com/office/drawing/2014/main" id="{FE94C13C-B00C-413E-BE1E-57C879396F08}"/>
               </a:ext>
             </a:extLst>
           </p:cNvPr>
@@ -3436,7 +3436,7 @@
           <p:cNvPr id="13" name="accent-3">
             <a:extLst xmlns:a="http://schemas.openxmlformats.org/drawingml/2006/main">
               <a:ext uri="{FF2B5EF4-FFF2-40B4-BE49-F238E27FC236}">
-                <a16:creationId xmlns:a16="http://schemas.microsoft.com/office/drawing/2014/main" id="{4A05F372-9B24-4400-B82C-A1A8014264F6}"/>
+                <a16:creationId xmlns:a16="http://schemas.microsoft.com/office/drawing/2014/main" id="{CAF11D1D-672D-4AB2-871B-B46E472DEDE4}"/>
               </a:ext>
             </a:extLst>
           </p:cNvPr>
@@ -3469,7 +3469,7 @@
           <p:cNvPr id="14" name="stage-01">
             <a:extLst xmlns:a="http://schemas.openxmlformats.org/drawingml/2006/main">
               <a:ext uri="{FF2B5EF4-FFF2-40B4-BE49-F238E27FC236}">
-                <a16:creationId xmlns:a16="http://schemas.microsoft.com/office/drawing/2014/main" id="{CE0DC271-715A-4678-9689-A6AA713C3C13}"/>
+                <a16:creationId xmlns:a16="http://schemas.microsoft.com/office/drawing/2014/main" id="{5638D0EF-2A54-4261-A58C-B4E3A446D07E}"/>
               </a:ext>
             </a:extLst>
           </p:cNvPr>
@@ -3525,7 +3525,7 @@
           <p:cNvPr id="15" name="stage-02">
             <a:extLst xmlns:a="http://schemas.openxmlformats.org/drawingml/2006/main">
               <a:ext uri="{FF2B5EF4-FFF2-40B4-BE49-F238E27FC236}">
-                <a16:creationId xmlns:a16="http://schemas.microsoft.com/office/drawing/2014/main" id="{FCEBC89E-E452-4CA6-AB4D-126DC8B0A636}"/>
+                <a16:creationId xmlns:a16="http://schemas.microsoft.com/office/drawing/2014/main" id="{53CDB5AE-156B-40B2-9DFD-E4EEC6EE6A80}"/>
               </a:ext>
             </a:extLst>
           </p:cNvPr>
@@ -3581,7 +3581,7 @@
           <p:cNvPr id="16" name="stage-03">
             <a:extLst xmlns:a="http://schemas.openxmlformats.org/drawingml/2006/main">
               <a:ext uri="{FF2B5EF4-FFF2-40B4-BE49-F238E27FC236}">
-                <a16:creationId xmlns:a16="http://schemas.microsoft.com/office/drawing/2014/main" id="{33ADEF4B-37C8-4EBF-997E-F29870D86399}"/>
+                <a16:creationId xmlns:a16="http://schemas.microsoft.com/office/drawing/2014/main" id="{9F267384-249B-4B63-8617-78450F8BE24A}"/>
               </a:ext>
             </a:extLst>
           </p:cNvPr>
@@ -3635,7 +3635,7 @@
     </p:spTree>
     <p:extLst>
       <p:ext uri="{BB962C8B-B14F-4D97-AF65-F5344CB8AC3E}">
-        <p14:creationId xmlns:p14="http://schemas.microsoft.com/office/powerpoint/2010/main" val="2096960865"/>
+        <p14:creationId xmlns:p14="http://schemas.microsoft.com/office/powerpoint/2010/main" val="1470731832"/>
       </p:ext>
     </p:extLst>
   </p:cSld>
@@ -3666,7 +3666,7 @@
           <p:cNvPr id="7" name="accent-4">
             <a:extLst xmlns:a="http://schemas.openxmlformats.org/drawingml/2006/main">
               <a:ext uri="{FF2B5EF4-FFF2-40B4-BE49-F238E27FC236}">
-                <a16:creationId xmlns:a16="http://schemas.microsoft.com/office/drawing/2014/main" id="{3D65D927-D365-482B-A822-D5B4A667E3AD}"/>
+                <a16:creationId xmlns:a16="http://schemas.microsoft.com/office/drawing/2014/main" id="{233D1A92-3265-4466-B583-33556E1B6CBC}"/>
               </a:ext>
             </a:extLst>
           </p:cNvPr>
@@ -3699,7 +3699,7 @@
           <p:cNvPr id="2" name="safety-title">
             <a:extLst xmlns:a="http://schemas.openxmlformats.org/drawingml/2006/main">
               <a:ext uri="{FF2B5EF4-FFF2-40B4-BE49-F238E27FC236}">
-                <a16:creationId xmlns:a16="http://schemas.microsoft.com/office/drawing/2014/main" id="{6EE9E39B-FEFA-4D43-94C5-AA4DAFB5D736}"/>
+                <a16:creationId xmlns:a16="http://schemas.microsoft.com/office/drawing/2014/main" id="{133DF0BA-5D29-4F0F-B851-6BE6AE85C10C}"/>
               </a:ext>
             </a:extLst>
           </p:cNvPr>
@@ -3755,7 +3755,7 @@
           <p:cNvPr id="3" name="safety-body">
             <a:extLst xmlns:a="http://schemas.openxmlformats.org/drawingml/2006/main">
               <a:ext uri="{FF2B5EF4-FFF2-40B4-BE49-F238E27FC236}">
-                <a16:creationId xmlns:a16="http://schemas.microsoft.com/office/drawing/2014/main" id="{669E76EB-3C76-4419-9F6C-7EC4B24C5569}"/>
+                <a16:creationId xmlns:a16="http://schemas.microsoft.com/office/drawing/2014/main" id="{B2AE6CC8-D55B-41AB-A65D-8965408C0D92}"/>
               </a:ext>
             </a:extLst>
           </p:cNvPr>
@@ -3869,7 +3869,7 @@
           <p:cNvPr id="4" name="safety-callout">
             <a:extLst xmlns:a="http://schemas.openxmlformats.org/drawingml/2006/main">
               <a:ext uri="{FF2B5EF4-FFF2-40B4-BE49-F238E27FC236}">
-                <a16:creationId xmlns:a16="http://schemas.microsoft.com/office/drawing/2014/main" id="{7F5194F4-F145-4B99-95B6-6681E130BFFE}"/>
+                <a16:creationId xmlns:a16="http://schemas.microsoft.com/office/drawing/2014/main" id="{28FFE02E-EA6E-4C5A-90B6-2BC45A4811BF}"/>
               </a:ext>
             </a:extLst>
           </p:cNvPr>
@@ -3929,7 +3929,7 @@
           <p:nvPr/>
         </p:nvPicPr>
         <p:blipFill>
-          <a:blip xmlns:r="http://schemas.openxmlformats.org/officeDocument/2006/relationships" xmlns:a="http://schemas.openxmlformats.org/drawingml/2006/main" r:embed="R1239a92e4eab4183"/>
+          <a:blip xmlns:r="http://schemas.openxmlformats.org/officeDocument/2006/relationships" xmlns:a="http://schemas.openxmlformats.org/drawingml/2006/main" r:embed="R8710930dc2f2419f"/>
           <a:stretch xmlns:a="http://schemas.openxmlformats.org/drawingml/2006/main"/>
         </p:blipFill>
         <p:spPr>
@@ -3949,7 +3949,7 @@
           <p:cNvPr id="6" name="screenshot-caption">
             <a:extLst xmlns:a="http://schemas.openxmlformats.org/drawingml/2006/main">
               <a:ext uri="{FF2B5EF4-FFF2-40B4-BE49-F238E27FC236}">
-                <a16:creationId xmlns:a16="http://schemas.microsoft.com/office/drawing/2014/main" id="{0F7D7CAC-C705-48FC-8A0E-3E777A1FB454}"/>
+                <a16:creationId xmlns:a16="http://schemas.microsoft.com/office/drawing/2014/main" id="{287B7693-0512-467A-9701-90C3735EB033}"/>
               </a:ext>
             </a:extLst>
           </p:cNvPr>
@@ -3997,7 +3997,7 @@
     </p:spTree>
     <p:extLst>
       <p:ext uri="{BB962C8B-B14F-4D97-AF65-F5344CB8AC3E}">
-        <p14:creationId xmlns:p14="http://schemas.microsoft.com/office/powerpoint/2010/main" val="1557940164"/>
+        <p14:creationId xmlns:p14="http://schemas.microsoft.com/office/powerpoint/2010/main" val="923867418"/>
       </p:ext>
     </p:extLst>
   </p:cSld>
@@ -4028,7 +4028,7 @@
           <p:cNvPr id="14" name="Rounded-Rectangle-5-1">
             <a:extLst xmlns:a="http://schemas.openxmlformats.org/drawingml/2006/main">
               <a:ext uri="{FF2B5EF4-FFF2-40B4-BE49-F238E27FC236}">
-                <a16:creationId xmlns:a16="http://schemas.microsoft.com/office/drawing/2014/main" id="{32127819-3FA9-4867-869D-71300057B793}"/>
+                <a16:creationId xmlns:a16="http://schemas.microsoft.com/office/drawing/2014/main" id="{8B277B07-73D2-4989-BD65-46E890C7A8BA}"/>
               </a:ext>
             </a:extLst>
           </p:cNvPr>
@@ -4057,7 +4057,7 @@
           <p:cNvPr id="2" name="Rounded-Rectangle-6-2">
             <a:extLst xmlns:a="http://schemas.openxmlformats.org/drawingml/2006/main">
               <a:ext uri="{FF2B5EF4-FFF2-40B4-BE49-F238E27FC236}">
-                <a16:creationId xmlns:a16="http://schemas.microsoft.com/office/drawing/2014/main" id="{C19031F9-9A55-468A-BC4F-D3EAC9C0B61C}"/>
+                <a16:creationId xmlns:a16="http://schemas.microsoft.com/office/drawing/2014/main" id="{DE3C2DA1-4194-49D4-B9D3-9151D2A5A77C}"/>
               </a:ext>
             </a:extLst>
           </p:cNvPr>
@@ -4086,7 +4086,7 @@
           <p:cNvPr id="3" name="Rounded-Rectangle-7-3">
             <a:extLst xmlns:a="http://schemas.openxmlformats.org/drawingml/2006/main">
               <a:ext uri="{FF2B5EF4-FFF2-40B4-BE49-F238E27FC236}">
-                <a16:creationId xmlns:a16="http://schemas.microsoft.com/office/drawing/2014/main" id="{E0917E1E-1178-4793-AC59-BC73EFC8C452}"/>
+                <a16:creationId xmlns:a16="http://schemas.microsoft.com/office/drawing/2014/main" id="{91264EBB-9DEA-43D0-959E-5632DCA1FB14}"/>
               </a:ext>
             </a:extLst>
           </p:cNvPr>
@@ -4115,7 +4115,7 @@
           <p:cNvPr id="4" name="Slide-Number-Placeholder-1-4">
             <a:extLst xmlns:a="http://schemas.openxmlformats.org/drawingml/2006/main">
               <a:ext uri="{FF2B5EF4-FFF2-40B4-BE49-F238E27FC236}">
-                <a16:creationId xmlns:a16="http://schemas.microsoft.com/office/drawing/2014/main" id="{EF0BD66B-437F-4BCA-BEC6-1CB17F4EA2B9}"/>
+                <a16:creationId xmlns:a16="http://schemas.microsoft.com/office/drawing/2014/main" id="{5690DB8E-CEA2-4125-8BB6-0B21128D6404}"/>
               </a:ext>
             </a:extLst>
           </p:cNvPr>
@@ -4158,7 +4158,7 @@
           <p:cNvPr id="5" name="Title-2-5">
             <a:extLst xmlns:a="http://schemas.openxmlformats.org/drawingml/2006/main">
               <a:ext uri="{FF2B5EF4-FFF2-40B4-BE49-F238E27FC236}">
-                <a16:creationId xmlns:a16="http://schemas.microsoft.com/office/drawing/2014/main" id="{1A4E3BB9-8140-4581-A3C2-591A2DCAB1BD}"/>
+                <a16:creationId xmlns:a16="http://schemas.microsoft.com/office/drawing/2014/main" id="{CEC05650-12B3-4F54-A767-496B4FA39CE7}"/>
               </a:ext>
             </a:extLst>
           </p:cNvPr>
@@ -4215,7 +4215,7 @@
           <p:cNvPr id="6" name="Content-Placeholder-9-6">
             <a:extLst xmlns:a="http://schemas.openxmlformats.org/drawingml/2006/main">
               <a:ext uri="{FF2B5EF4-FFF2-40B4-BE49-F238E27FC236}">
-                <a16:creationId xmlns:a16="http://schemas.microsoft.com/office/drawing/2014/main" id="{57EE3070-80B1-4982-AB3E-8D29D99E37A9}"/>
+                <a16:creationId xmlns:a16="http://schemas.microsoft.com/office/drawing/2014/main" id="{1FEFCBCF-5C2A-49CC-A63B-FCE4B2A70A4A}"/>
               </a:ext>
             </a:extLst>
           </p:cNvPr>
@@ -4272,7 +4272,7 @@
           <p:cNvPr id="7" name="Content-Placeholder-10-7">
             <a:extLst xmlns:a="http://schemas.openxmlformats.org/drawingml/2006/main">
               <a:ext uri="{FF2B5EF4-FFF2-40B4-BE49-F238E27FC236}">
-                <a16:creationId xmlns:a16="http://schemas.microsoft.com/office/drawing/2014/main" id="{1ACB4279-4C94-4DA6-BAB7-BBFE8CD43F76}"/>
+                <a16:creationId xmlns:a16="http://schemas.microsoft.com/office/drawing/2014/main" id="{14C6D581-6B65-4B53-BD1A-5368A979CA80}"/>
               </a:ext>
             </a:extLst>
           </p:cNvPr>
@@ -4329,7 +4329,7 @@
           <p:cNvPr id="8" name="Content-Placeholder-11-8">
             <a:extLst xmlns:a="http://schemas.openxmlformats.org/drawingml/2006/main">
               <a:ext uri="{FF2B5EF4-FFF2-40B4-BE49-F238E27FC236}">
-                <a16:creationId xmlns:a16="http://schemas.microsoft.com/office/drawing/2014/main" id="{ECFD7965-B595-40AC-B06D-005875FE54F8}"/>
+                <a16:creationId xmlns:a16="http://schemas.microsoft.com/office/drawing/2014/main" id="{5EB9065D-F178-41F1-9909-E986A2C52D05}"/>
               </a:ext>
             </a:extLst>
           </p:cNvPr>
@@ -4386,7 +4386,7 @@
           <p:cNvPr id="9" name="Content-Placeholder-9-9">
             <a:extLst xmlns:a="http://schemas.openxmlformats.org/drawingml/2006/main">
               <a:ext uri="{FF2B5EF4-FFF2-40B4-BE49-F238E27FC236}">
-                <a16:creationId xmlns:a16="http://schemas.microsoft.com/office/drawing/2014/main" id="{EE5C697A-9600-46C1-ABCE-1F28FC01C373}"/>
+                <a16:creationId xmlns:a16="http://schemas.microsoft.com/office/drawing/2014/main" id="{AEA00C99-9597-4A75-9F56-2DC25FEA836C}"/>
               </a:ext>
             </a:extLst>
           </p:cNvPr>
@@ -4433,7 +4433,7 @@
                 <a:ea typeface="Aptos"/>
                 <a:cs typeface="Aptos"/>
               </a:rPr>
-              <a:t>28 / 28</a:t>
+              <a:t>33 / 33</a:t>
             </a:r>
           </a:p>
         </p:txBody>
@@ -4443,7 +4443,7 @@
           <p:cNvPr id="10" name="Content-Placeholder-9-10">
             <a:extLst xmlns:a="http://schemas.openxmlformats.org/drawingml/2006/main">
               <a:ext uri="{FF2B5EF4-FFF2-40B4-BE49-F238E27FC236}">
-                <a16:creationId xmlns:a16="http://schemas.microsoft.com/office/drawing/2014/main" id="{9AE5AD8E-BAB1-4299-8CAB-F136D71D134E}"/>
+                <a16:creationId xmlns:a16="http://schemas.microsoft.com/office/drawing/2014/main" id="{F3DBA2ED-F8D1-4B90-BA92-EE20376D274C}"/>
               </a:ext>
             </a:extLst>
           </p:cNvPr>
@@ -4490,7 +4490,7 @@
                 <a:ea typeface="Aptos"/>
                 <a:cs typeface="Aptos"/>
               </a:rPr>
-              <a:t>5 / 5</a:t>
+              <a:t>6 / 6</a:t>
             </a:r>
           </a:p>
         </p:txBody>
@@ -4500,7 +4500,7 @@
           <p:cNvPr id="11" name="Content-Placeholder-9-11">
             <a:extLst xmlns:a="http://schemas.openxmlformats.org/drawingml/2006/main">
               <a:ext uri="{FF2B5EF4-FFF2-40B4-BE49-F238E27FC236}">
-                <a16:creationId xmlns:a16="http://schemas.microsoft.com/office/drawing/2014/main" id="{749C7069-72DF-485A-A7A3-A325885B8AEC}"/>
+                <a16:creationId xmlns:a16="http://schemas.microsoft.com/office/drawing/2014/main" id="{5875E70A-2F77-4FC3-A6C7-5737D0E0ED92}"/>
               </a:ext>
             </a:extLst>
           </p:cNvPr>
@@ -4557,7 +4557,7 @@
           <p:cNvPr id="12" name="Content-Placeholder-15-12">
             <a:extLst xmlns:a="http://schemas.openxmlformats.org/drawingml/2006/main">
               <a:ext uri="{FF2B5EF4-FFF2-40B4-BE49-F238E27FC236}">
-                <a16:creationId xmlns:a16="http://schemas.microsoft.com/office/drawing/2014/main" id="{0AC455EA-DEAB-45D0-B0B3-042E5DB3CE60}"/>
+                <a16:creationId xmlns:a16="http://schemas.microsoft.com/office/drawing/2014/main" id="{7F9C1A90-EE25-46A4-B681-E216AA744AA1}"/>
               </a:ext>
             </a:extLst>
           </p:cNvPr>
@@ -4641,7 +4641,7 @@
           <p:cNvPr id="13" name="accent-5">
             <a:extLst xmlns:a="http://schemas.openxmlformats.org/drawingml/2006/main">
               <a:ext uri="{FF2B5EF4-FFF2-40B4-BE49-F238E27FC236}">
-                <a16:creationId xmlns:a16="http://schemas.microsoft.com/office/drawing/2014/main" id="{1C72FC4F-4E5A-4320-8A26-542375A5E229}"/>
+                <a16:creationId xmlns:a16="http://schemas.microsoft.com/office/drawing/2014/main" id="{8DC3055C-315C-40D5-923E-DF34808B6D90}"/>
               </a:ext>
             </a:extLst>
           </p:cNvPr>
@@ -4672,7 +4672,7 @@
     </p:spTree>
     <p:extLst>
       <p:ext uri="{BB962C8B-B14F-4D97-AF65-F5344CB8AC3E}">
-        <p14:creationId xmlns:p14="http://schemas.microsoft.com/office/powerpoint/2010/main" val="1849818267"/>
+        <p14:creationId xmlns:p14="http://schemas.microsoft.com/office/powerpoint/2010/main" val="669821838"/>
       </p:ext>
     </p:extLst>
   </p:cSld>
@@ -4703,7 +4703,7 @@
           <p:cNvPr id="5" name="Title-3-1">
             <a:extLst xmlns:a="http://schemas.openxmlformats.org/drawingml/2006/main">
               <a:ext uri="{FF2B5EF4-FFF2-40B4-BE49-F238E27FC236}">
-                <a16:creationId xmlns:a16="http://schemas.microsoft.com/office/drawing/2014/main" id="{FE98BA7B-8F4F-4F73-B563-4FE2DB8C967C}"/>
+                <a16:creationId xmlns:a16="http://schemas.microsoft.com/office/drawing/2014/main" id="{40EEFB54-F03B-4605-9830-DB00D8D25814}"/>
               </a:ext>
             </a:extLst>
           </p:cNvPr>
@@ -4760,7 +4760,7 @@
           <p:cNvPr id="2" name="Subtitle-4-2">
             <a:extLst xmlns:a="http://schemas.openxmlformats.org/drawingml/2006/main">
               <a:ext uri="{FF2B5EF4-FFF2-40B4-BE49-F238E27FC236}">
-                <a16:creationId xmlns:a16="http://schemas.microsoft.com/office/drawing/2014/main" id="{18779017-783C-4BBE-B8D4-6A57745B6B07}"/>
+                <a16:creationId xmlns:a16="http://schemas.microsoft.com/office/drawing/2014/main" id="{AB626A06-BBFD-4854-9A4E-99FDDFEBAD06}"/>
               </a:ext>
             </a:extLst>
           </p:cNvPr>
@@ -4871,7 +4871,7 @@
           <p:cNvPr id="3" name="Subtitle-4-3">
             <a:extLst xmlns:a="http://schemas.openxmlformats.org/drawingml/2006/main">
               <a:ext uri="{FF2B5EF4-FFF2-40B4-BE49-F238E27FC236}">
-                <a16:creationId xmlns:a16="http://schemas.microsoft.com/office/drawing/2014/main" id="{BC4B3B3F-170B-4B45-A518-45618D8B04DE}"/>
+                <a16:creationId xmlns:a16="http://schemas.microsoft.com/office/drawing/2014/main" id="{3D24641E-7465-408E-85FB-52971B3F2F0F}"/>
               </a:ext>
             </a:extLst>
           </p:cNvPr>
@@ -4928,7 +4928,7 @@
           <p:cNvPr id="4" name="accent-6">
             <a:extLst xmlns:a="http://schemas.openxmlformats.org/drawingml/2006/main">
               <a:ext uri="{FF2B5EF4-FFF2-40B4-BE49-F238E27FC236}">
-                <a16:creationId xmlns:a16="http://schemas.microsoft.com/office/drawing/2014/main" id="{21A3EB85-A845-497D-8127-15A8294E6BF3}"/>
+                <a16:creationId xmlns:a16="http://schemas.microsoft.com/office/drawing/2014/main" id="{6E4629E0-8D6C-4BAC-A4E3-1087DB8253EF}"/>
               </a:ext>
             </a:extLst>
           </p:cNvPr>
@@ -4959,7 +4959,7 @@
     </p:spTree>
     <p:extLst>
       <p:ext uri="{BB962C8B-B14F-4D97-AF65-F5344CB8AC3E}">
-        <p14:creationId xmlns:p14="http://schemas.microsoft.com/office/powerpoint/2010/main" val="89077359"/>
+        <p14:creationId xmlns:p14="http://schemas.microsoft.com/office/powerpoint/2010/main" val="1274749365"/>
       </p:ext>
     </p:extLst>
   </p:cSld>

</xml_diff>